<commit_message>
Implement dynamic row height estimation and font sizing in table_slide.py for improved table layout. Update test presentation file to reflect new table structure and content adjustments.
</commit_message>
<xml_diff>
--- a/src/tests/test_table_slide.pptx
+++ b/src/tests/test_table_slide.pptx
@@ -3119,7 +3119,7 @@
               </a:defRPr>
             </a:pPr>
             <a:r>
-              <a:t>FY25 METRICS</a:t>
+              <a:t>Top Risks &amp; Signals</a:t>
             </a:r>
           </a:p>
         </p:txBody>
@@ -3155,7 +3155,7 @@
               </a:defRPr>
             </a:pPr>
             <a:r>
-              <a:t>Highlights include strong Service growth (+14%) and Net income (+19%), driven by strategic mix shifts and robust hardware performance.</a:t>
+              <a:t>Condensed from FY2024 10-K Item 1A risk factors; indicators to monitor in 2025</a:t>
             </a:r>
           </a:p>
         </p:txBody>
@@ -3169,8 +3169,8 @@
           <p:nvPr/>
         </p:nvGraphicFramePr>
         <p:xfrm>
-          <a:off x="685800" y="1371600"/>
-          <a:ext cx="7772400" cy="5029200"/>
+          <a:off x="685800" y="1625600"/>
+          <a:ext cx="7772400" cy="4521196"/>
         </p:xfrm>
         <a:graphic>
           <a:graphicData uri="http://schemas.openxmlformats.org/drawingml/2006/table">
@@ -3179,18 +3179,19 @@
                 <a:tableStyleId>{5C22544A-7EE6-4342-B048-85BDC9FD1C3A}</a:tableStyleId>
               </a:tblPr>
               <a:tblGrid>
-                <a:gridCol w="2590800"/>
-                <a:gridCol w="2590800"/>
-                <a:gridCol w="2590800"/>
+                <a:gridCol w="1943100"/>
+                <a:gridCol w="1943100"/>
+                <a:gridCol w="1943100"/>
+                <a:gridCol w="1943100"/>
               </a:tblGrid>
-              <a:tr h="386861">
+              <a:tr h="360680">
                 <a:tc>
                   <a:txBody>
                     <a:bodyPr/>
                     <a:lstStyle/>
                     <a:p>
                       <a:pPr algn="ctr">
-                        <a:defRPr sz="1400" b="1">
+                        <a:defRPr sz="1000" b="1">
                           <a:solidFill>
                             <a:srgbClr val="333333"/>
                           </a:solidFill>
@@ -3198,7 +3199,7 @@
                         </a:defRPr>
                       </a:pPr>
                       <a:r>
-                        <a:t>Metric</a:t>
+                        <a:t>Risk</a:t>
                       </a:r>
                     </a:p>
                   </a:txBody>
@@ -3214,7 +3215,7 @@
                     <a:lstStyle/>
                     <a:p>
                       <a:pPr algn="ctr">
-                        <a:defRPr sz="1400" b="1">
+                        <a:defRPr sz="1000" b="1">
                           <a:solidFill>
                             <a:srgbClr val="333333"/>
                           </a:solidFill>
@@ -3222,7 +3223,7 @@
                         </a:defRPr>
                       </a:pPr>
                       <a:r>
-                        <a:t>FY25 (USD m)</a:t>
+                        <a:t>Impact</a:t>
                       </a:r>
                     </a:p>
                   </a:txBody>
@@ -3238,7 +3239,7 @@
                     <a:lstStyle/>
                     <a:p>
                       <a:pPr algn="ctr">
-                        <a:defRPr sz="1400" b="1">
+                        <a:defRPr sz="1000" b="1">
                           <a:solidFill>
                             <a:srgbClr val="333333"/>
                           </a:solidFill>
@@ -3246,7 +3247,31 @@
                         </a:defRPr>
                       </a:pPr>
                       <a:r>
-                        <a:t>YoY</a:t>
+                        <a:t>Horizon</a:t>
+                      </a:r>
+                    </a:p>
+                  </a:txBody>
+                  <a:tcPr anchor="ctr">
+                    <a:solidFill>
+                      <a:srgbClr val="A5E2F9"/>
+                    </a:solidFill>
+                  </a:tcPr>
+                </a:tc>
+                <a:tc>
+                  <a:txBody>
+                    <a:bodyPr/>
+                    <a:lstStyle/>
+                    <a:p>
+                      <a:pPr algn="ctr">
+                        <a:defRPr sz="1000" b="1">
+                          <a:solidFill>
+                            <a:srgbClr val="333333"/>
+                          </a:solidFill>
+                          <a:latin typeface="Albert Sans"/>
+                        </a:defRPr>
+                      </a:pPr>
+                      <a:r>
+                        <a:t>Leading indicators</a:t>
                       </a:r>
                     </a:p>
                   </a:txBody>
@@ -3257,14 +3282,14 @@
                   </a:tcPr>
                 </a:tc>
               </a:tr>
-              <a:tr h="386861">
+              <a:tr h="662939">
                 <a:tc>
                   <a:txBody>
                     <a:bodyPr/>
                     <a:lstStyle/>
                     <a:p>
                       <a:pPr algn="ctr">
-                        <a:defRPr sz="1300">
+                        <a:defRPr sz="900">
                           <a:solidFill>
                             <a:srgbClr val="333333"/>
                           </a:solidFill>
@@ -3272,7 +3297,7 @@
                         </a:defRPr>
                       </a:pPr>
                       <a:r>
-                        <a:t>Net sales</a:t>
+                        <a:t>BTC drawdown → liquidity stress</a:t>
                       </a:r>
                     </a:p>
                   </a:txBody>
@@ -3288,7 +3313,7 @@
                     <a:lstStyle/>
                     <a:p>
                       <a:pPr algn="ctr">
-                        <a:defRPr sz="1300">
+                        <a:defRPr sz="900">
                           <a:solidFill>
                             <a:srgbClr val="333333"/>
                           </a:solidFill>
@@ -3296,7 +3321,7 @@
                         </a:defRPr>
                       </a:pPr>
                       <a:r>
-                        <a:t>416,161</a:t>
+                        <a:t>High</a:t>
                       </a:r>
                     </a:p>
                   </a:txBody>
@@ -3312,7 +3337,7 @@
                     <a:lstStyle/>
                     <a:p>
                       <a:pPr algn="ctr">
-                        <a:defRPr sz="1300">
+                        <a:defRPr sz="900">
                           <a:solidFill>
                             <a:srgbClr val="333333"/>
                           </a:solidFill>
@@ -3320,33 +3345,7 @@
                         </a:defRPr>
                       </a:pPr>
                       <a:r>
-                        <a:t>+6%</a:t>
-                      </a:r>
-                    </a:p>
-                  </a:txBody>
-                  <a:tcPr anchor="ctr">
-                    <a:solidFill>
-                      <a:srgbClr val="E5F6FD"/>
-                    </a:solidFill>
-                  </a:tcPr>
-                </a:tc>
-              </a:tr>
-              <a:tr h="386861">
-                <a:tc>
-                  <a:txBody>
-                    <a:bodyPr/>
-                    <a:lstStyle/>
-                    <a:p>
-                      <a:pPr algn="ctr">
-                        <a:defRPr sz="1300">
-                          <a:solidFill>
-                            <a:srgbClr val="333333"/>
-                          </a:solidFill>
-                          <a:latin typeface="Albert Sans"/>
-                        </a:defRPr>
-                      </a:pPr>
-                      <a:r>
-                        <a:t>Net income</a:t>
+                        <a:t>0–24 mo</a:t>
                       </a:r>
                     </a:p>
                   </a:txBody>
@@ -3362,7 +3361,7 @@
                     <a:lstStyle/>
                     <a:p>
                       <a:pPr algn="ctr">
-                        <a:defRPr sz="1300">
+                        <a:defRPr sz="900">
                           <a:solidFill>
                             <a:srgbClr val="333333"/>
                           </a:solidFill>
@@ -3370,7 +3369,33 @@
                         </a:defRPr>
                       </a:pPr>
                       <a:r>
-                        <a:t>112,010</a:t>
+                        <a:t>BTC price; MSTR premium/NAV; convert/ATM terms; credit spreads</a:t>
+                      </a:r>
+                    </a:p>
+                  </a:txBody>
+                  <a:tcPr anchor="ctr">
+                    <a:solidFill>
+                      <a:srgbClr val="E5F6FD"/>
+                    </a:solidFill>
+                  </a:tcPr>
+                </a:tc>
+              </a:tr>
+              <a:tr h="502920">
+                <a:tc>
+                  <a:txBody>
+                    <a:bodyPr/>
+                    <a:lstStyle/>
+                    <a:p>
+                      <a:pPr algn="ctr">
+                        <a:defRPr sz="900">
+                          <a:solidFill>
+                            <a:srgbClr val="333333"/>
+                          </a:solidFill>
+                          <a:latin typeface="Albert Sans"/>
+                        </a:defRPr>
+                      </a:pPr>
+                      <a:r>
+                        <a:t>Premium compression vs spot BTC ETPs</a:t>
                       </a:r>
                     </a:p>
                   </a:txBody>
@@ -3386,7 +3411,7 @@
                     <a:lstStyle/>
                     <a:p>
                       <a:pPr algn="ctr">
-                        <a:defRPr sz="1300">
+                        <a:defRPr sz="900">
                           <a:solidFill>
                             <a:srgbClr val="333333"/>
                           </a:solidFill>
@@ -3394,33 +3419,7 @@
                         </a:defRPr>
                       </a:pPr>
                       <a:r>
-                        <a:t>+19%</a:t>
-                      </a:r>
-                    </a:p>
-                  </a:txBody>
-                  <a:tcPr anchor="ctr">
-                    <a:solidFill>
-                      <a:srgbClr val="E5F6FD"/>
-                    </a:solidFill>
-                  </a:tcPr>
-                </a:tc>
-              </a:tr>
-              <a:tr h="386861">
-                <a:tc>
-                  <a:txBody>
-                    <a:bodyPr/>
-                    <a:lstStyle/>
-                    <a:p>
-                      <a:pPr algn="ctr">
-                        <a:defRPr sz="1300">
-                          <a:solidFill>
-                            <a:srgbClr val="333333"/>
-                          </a:solidFill>
-                          <a:latin typeface="Albert Sans"/>
-                        </a:defRPr>
-                      </a:pPr>
-                      <a:r>
-                        <a:t>Services net sales</a:t>
+                        <a:t>High</a:t>
                       </a:r>
                     </a:p>
                   </a:txBody>
@@ -3436,7 +3435,7 @@
                     <a:lstStyle/>
                     <a:p>
                       <a:pPr algn="ctr">
-                        <a:defRPr sz="1300">
+                        <a:defRPr sz="900">
                           <a:solidFill>
                             <a:srgbClr val="333333"/>
                           </a:solidFill>
@@ -3444,7 +3443,7 @@
                         </a:defRPr>
                       </a:pPr>
                       <a:r>
-                        <a:t>109,158</a:t>
+                        <a:t>0–36 mo</a:t>
                       </a:r>
                     </a:p>
                   </a:txBody>
@@ -3460,7 +3459,7 @@
                     <a:lstStyle/>
                     <a:p>
                       <a:pPr algn="ctr">
-                        <a:defRPr sz="1300">
+                        <a:defRPr sz="900">
                           <a:solidFill>
                             <a:srgbClr val="333333"/>
                           </a:solidFill>
@@ -3468,7 +3467,7 @@
                         </a:defRPr>
                       </a:pPr>
                       <a:r>
-                        <a:t>+14%</a:t>
+                        <a:t>ETP AUM growth; MSTR premium; borrow rates</a:t>
                       </a:r>
                     </a:p>
                   </a:txBody>
@@ -3479,14 +3478,14 @@
                   </a:tcPr>
                 </a:tc>
               </a:tr>
-              <a:tr h="386861">
+              <a:tr h="662939">
                 <a:tc>
                   <a:txBody>
                     <a:bodyPr/>
                     <a:lstStyle/>
                     <a:p>
                       <a:pPr algn="ctr">
-                        <a:defRPr sz="1300">
+                        <a:defRPr sz="900">
                           <a:solidFill>
                             <a:srgbClr val="333333"/>
                           </a:solidFill>
@@ -3494,7 +3493,7 @@
                         </a:defRPr>
                       </a:pPr>
                       <a:r>
-                        <a:t>Net sales</a:t>
+                        <a:t>Financing shut → fixed-charge strain</a:t>
                       </a:r>
                     </a:p>
                   </a:txBody>
@@ -3510,7 +3509,7 @@
                     <a:lstStyle/>
                     <a:p>
                       <a:pPr algn="ctr">
-                        <a:defRPr sz="1300">
+                        <a:defRPr sz="900">
                           <a:solidFill>
                             <a:srgbClr val="333333"/>
                           </a:solidFill>
@@ -3518,7 +3517,7 @@
                         </a:defRPr>
                       </a:pPr>
                       <a:r>
-                        <a:t>416,161</a:t>
+                        <a:t>High</a:t>
                       </a:r>
                     </a:p>
                   </a:txBody>
@@ -3534,7 +3533,7 @@
                     <a:lstStyle/>
                     <a:p>
                       <a:pPr algn="ctr">
-                        <a:defRPr sz="1300">
+                        <a:defRPr sz="900">
                           <a:solidFill>
                             <a:srgbClr val="333333"/>
                           </a:solidFill>
@@ -3542,33 +3541,7 @@
                         </a:defRPr>
                       </a:pPr>
                       <a:r>
-                        <a:t>+6%</a:t>
-                      </a:r>
-                    </a:p>
-                  </a:txBody>
-                  <a:tcPr anchor="ctr">
-                    <a:solidFill>
-                      <a:srgbClr val="E5F6FD"/>
-                    </a:solidFill>
-                  </a:tcPr>
-                </a:tc>
-              </a:tr>
-              <a:tr h="386861">
-                <a:tc>
-                  <a:txBody>
-                    <a:bodyPr/>
-                    <a:lstStyle/>
-                    <a:p>
-                      <a:pPr algn="ctr">
-                        <a:defRPr sz="1300">
-                          <a:solidFill>
-                            <a:srgbClr val="333333"/>
-                          </a:solidFill>
-                          <a:latin typeface="Albert Sans"/>
-                        </a:defRPr>
-                      </a:pPr>
-                      <a:r>
-                        <a:t>Net income</a:t>
+                        <a:t>0–24 mo</a:t>
                       </a:r>
                     </a:p>
                   </a:txBody>
@@ -3584,7 +3557,7 @@
                     <a:lstStyle/>
                     <a:p>
                       <a:pPr algn="ctr">
-                        <a:defRPr sz="1300">
+                        <a:defRPr sz="900">
                           <a:solidFill>
                             <a:srgbClr val="333333"/>
                           </a:solidFill>
@@ -3592,7 +3565,33 @@
                         </a:defRPr>
                       </a:pPr>
                       <a:r>
-                        <a:t>112,010</a:t>
+                        <a:t>Equity volatility; convert market conditions; preferred dividend settlement mix</a:t>
+                      </a:r>
+                    </a:p>
+                  </a:txBody>
+                  <a:tcPr anchor="ctr">
+                    <a:solidFill>
+                      <a:srgbClr val="E5F6FD"/>
+                    </a:solidFill>
+                  </a:tcPr>
+                </a:tc>
+              </a:tr>
+              <a:tr h="502920">
+                <a:tc>
+                  <a:txBody>
+                    <a:bodyPr/>
+                    <a:lstStyle/>
+                    <a:p>
+                      <a:pPr algn="ctr">
+                        <a:defRPr sz="900">
+                          <a:solidFill>
+                            <a:srgbClr val="333333"/>
+                          </a:solidFill>
+                          <a:latin typeface="Albert Sans"/>
+                        </a:defRPr>
+                      </a:pPr>
+                      <a:r>
+                        <a:t>Fair-value + CAMT cash-tax risk</a:t>
                       </a:r>
                     </a:p>
                   </a:txBody>
@@ -3608,7 +3607,7 @@
                     <a:lstStyle/>
                     <a:p>
                       <a:pPr algn="ctr">
-                        <a:defRPr sz="1300">
+                        <a:defRPr sz="900">
                           <a:solidFill>
                             <a:srgbClr val="333333"/>
                           </a:solidFill>
@@ -3616,33 +3615,7 @@
                         </a:defRPr>
                       </a:pPr>
                       <a:r>
-                        <a:t>+19%</a:t>
-                      </a:r>
-                    </a:p>
-                  </a:txBody>
-                  <a:tcPr anchor="ctr">
-                    <a:solidFill>
-                      <a:srgbClr val="E5F6FD"/>
-                    </a:solidFill>
-                  </a:tcPr>
-                </a:tc>
-              </a:tr>
-              <a:tr h="386861">
-                <a:tc>
-                  <a:txBody>
-                    <a:bodyPr/>
-                    <a:lstStyle/>
-                    <a:p>
-                      <a:pPr algn="ctr">
-                        <a:defRPr sz="1300">
-                          <a:solidFill>
-                            <a:srgbClr val="333333"/>
-                          </a:solidFill>
-                          <a:latin typeface="Albert Sans"/>
-                        </a:defRPr>
-                      </a:pPr>
-                      <a:r>
-                        <a:t>Services net sales</a:t>
+                        <a:t>Med–High</a:t>
                       </a:r>
                     </a:p>
                   </a:txBody>
@@ -3658,7 +3631,7 @@
                     <a:lstStyle/>
                     <a:p>
                       <a:pPr algn="ctr">
-                        <a:defRPr sz="1300">
+                        <a:defRPr sz="900">
                           <a:solidFill>
                             <a:srgbClr val="333333"/>
                           </a:solidFill>
@@ -3666,7 +3639,7 @@
                         </a:defRPr>
                       </a:pPr>
                       <a:r>
-                        <a:t>109,158</a:t>
+                        <a:t>12–48 mo</a:t>
                       </a:r>
                     </a:p>
                   </a:txBody>
@@ -3682,7 +3655,7 @@
                     <a:lstStyle/>
                     <a:p>
                       <a:pPr algn="ctr">
-                        <a:defRPr sz="1300">
+                        <a:defRPr sz="900">
                           <a:solidFill>
                             <a:srgbClr val="333333"/>
                           </a:solidFill>
@@ -3690,7 +3663,7 @@
                         </a:defRPr>
                       </a:pPr>
                       <a:r>
-                        <a:t>+14%</a:t>
+                        <a:t>BTC unrealized gains; CAMT guidance; projected AFSI</a:t>
                       </a:r>
                     </a:p>
                   </a:txBody>
@@ -3701,14 +3674,14 @@
                   </a:tcPr>
                 </a:tc>
               </a:tr>
-              <a:tr h="386861">
+              <a:tr h="662939">
                 <a:tc>
                   <a:txBody>
                     <a:bodyPr/>
                     <a:lstStyle/>
                     <a:p>
                       <a:pPr algn="ctr">
-                        <a:defRPr sz="1300">
+                        <a:defRPr sz="900">
                           <a:solidFill>
                             <a:srgbClr val="333333"/>
                           </a:solidFill>
@@ -3716,7 +3689,7 @@
                         </a:defRPr>
                       </a:pPr>
                       <a:r>
-                        <a:t>Net sales</a:t>
+                        <a:t>Custody/cyber tail risk</a:t>
                       </a:r>
                     </a:p>
                   </a:txBody>
@@ -3732,7 +3705,7 @@
                     <a:lstStyle/>
                     <a:p>
                       <a:pPr algn="ctr">
-                        <a:defRPr sz="1300">
+                        <a:defRPr sz="900">
                           <a:solidFill>
                             <a:srgbClr val="333333"/>
                           </a:solidFill>
@@ -3740,7 +3713,7 @@
                         </a:defRPr>
                       </a:pPr>
                       <a:r>
-                        <a:t>416,161</a:t>
+                        <a:t>High</a:t>
                       </a:r>
                     </a:p>
                   </a:txBody>
@@ -3756,7 +3729,7 @@
                     <a:lstStyle/>
                     <a:p>
                       <a:pPr algn="ctr">
-                        <a:defRPr sz="1300">
+                        <a:defRPr sz="900">
                           <a:solidFill>
                             <a:srgbClr val="333333"/>
                           </a:solidFill>
@@ -3764,33 +3737,7 @@
                         </a:defRPr>
                       </a:pPr>
                       <a:r>
-                        <a:t>+6%</a:t>
-                      </a:r>
-                    </a:p>
-                  </a:txBody>
-                  <a:tcPr anchor="ctr">
-                    <a:solidFill>
-                      <a:srgbClr val="E5F6FD"/>
-                    </a:solidFill>
-                  </a:tcPr>
-                </a:tc>
-              </a:tr>
-              <a:tr h="386861">
-                <a:tc>
-                  <a:txBody>
-                    <a:bodyPr/>
-                    <a:lstStyle/>
-                    <a:p>
-                      <a:pPr algn="ctr">
-                        <a:defRPr sz="1300">
-                          <a:solidFill>
-                            <a:srgbClr val="333333"/>
-                          </a:solidFill>
-                          <a:latin typeface="Albert Sans"/>
-                        </a:defRPr>
-                      </a:pPr>
-                      <a:r>
-                        <a:t>Net income</a:t>
+                        <a:t>0–60 mo</a:t>
                       </a:r>
                     </a:p>
                   </a:txBody>
@@ -3806,7 +3753,7 @@
                     <a:lstStyle/>
                     <a:p>
                       <a:pPr algn="ctr">
-                        <a:defRPr sz="1300">
+                        <a:defRPr sz="900">
                           <a:solidFill>
                             <a:srgbClr val="333333"/>
                           </a:solidFill>
@@ -3814,7 +3761,33 @@
                         </a:defRPr>
                       </a:pPr>
                       <a:r>
-                        <a:t>112,010</a:t>
+                        <a:t>Custodian incidents; SOC reports; regulatory actions vs custodians</a:t>
+                      </a:r>
+                    </a:p>
+                  </a:txBody>
+                  <a:tcPr anchor="ctr">
+                    <a:solidFill>
+                      <a:srgbClr val="E5F6FD"/>
+                    </a:solidFill>
+                  </a:tcPr>
+                </a:tc>
+              </a:tr>
+              <a:tr h="502920">
+                <a:tc>
+                  <a:txBody>
+                    <a:bodyPr/>
+                    <a:lstStyle/>
+                    <a:p>
+                      <a:pPr algn="ctr">
+                        <a:defRPr sz="900">
+                          <a:solidFill>
+                            <a:srgbClr val="333333"/>
+                          </a:solidFill>
+                          <a:latin typeface="Albert Sans"/>
+                        </a:defRPr>
+                      </a:pPr>
+                      <a:r>
+                        <a:t>Dual-class governance concentration</a:t>
                       </a:r>
                     </a:p>
                   </a:txBody>
@@ -3830,7 +3803,7 @@
                     <a:lstStyle/>
                     <a:p>
                       <a:pPr algn="ctr">
-                        <a:defRPr sz="1300">
+                        <a:defRPr sz="900">
                           <a:solidFill>
                             <a:srgbClr val="333333"/>
                           </a:solidFill>
@@ -3838,33 +3811,7 @@
                         </a:defRPr>
                       </a:pPr>
                       <a:r>
-                        <a:t>+19%</a:t>
-                      </a:r>
-                    </a:p>
-                  </a:txBody>
-                  <a:tcPr anchor="ctr">
-                    <a:solidFill>
-                      <a:srgbClr val="E5F6FD"/>
-                    </a:solidFill>
-                  </a:tcPr>
-                </a:tc>
-              </a:tr>
-              <a:tr h="386861">
-                <a:tc>
-                  <a:txBody>
-                    <a:bodyPr/>
-                    <a:lstStyle/>
-                    <a:p>
-                      <a:pPr algn="ctr">
-                        <a:defRPr sz="1300">
-                          <a:solidFill>
-                            <a:srgbClr val="333333"/>
-                          </a:solidFill>
-                          <a:latin typeface="Albert Sans"/>
-                        </a:defRPr>
-                      </a:pPr>
-                      <a:r>
-                        <a:t>Services net sales</a:t>
+                        <a:t>Medium</a:t>
                       </a:r>
                     </a:p>
                   </a:txBody>
@@ -3880,7 +3827,7 @@
                     <a:lstStyle/>
                     <a:p>
                       <a:pPr algn="ctr">
-                        <a:defRPr sz="1300">
+                        <a:defRPr sz="900">
                           <a:solidFill>
                             <a:srgbClr val="333333"/>
                           </a:solidFill>
@@ -3888,7 +3835,7 @@
                         </a:defRPr>
                       </a:pPr>
                       <a:r>
-                        <a:t>109,158</a:t>
+                        <a:t>Structural</a:t>
                       </a:r>
                     </a:p>
                   </a:txBody>
@@ -3904,7 +3851,7 @@
                     <a:lstStyle/>
                     <a:p>
                       <a:pPr algn="ctr">
-                        <a:defRPr sz="1300">
+                        <a:defRPr sz="900">
                           <a:solidFill>
                             <a:srgbClr val="333333"/>
                           </a:solidFill>
@@ -3912,7 +3859,7 @@
                         </a:defRPr>
                       </a:pPr>
                       <a:r>
-                        <a:t>+14%</a:t>
+                        <a:t>Insider actions; governance ratings; shareholder proposals</a:t>
                       </a:r>
                     </a:p>
                   </a:txBody>
@@ -3923,14 +3870,14 @@
                   </a:tcPr>
                 </a:tc>
               </a:tr>
-              <a:tr h="386861">
+              <a:tr h="662939">
                 <a:tc>
                   <a:txBody>
                     <a:bodyPr/>
                     <a:lstStyle/>
                     <a:p>
                       <a:pPr algn="ctr">
-                        <a:defRPr sz="1300">
+                        <a:defRPr sz="900">
                           <a:solidFill>
                             <a:srgbClr val="333333"/>
                           </a:solidFill>
@@ -3938,7 +3885,7 @@
                         </a:defRPr>
                       </a:pPr>
                       <a:r>
-                        <a:t>Net sales</a:t>
+                        <a:t>Software transition/erosion</a:t>
                       </a:r>
                     </a:p>
                   </a:txBody>
@@ -3954,7 +3901,7 @@
                     <a:lstStyle/>
                     <a:p>
                       <a:pPr algn="ctr">
-                        <a:defRPr sz="1300">
+                        <a:defRPr sz="900">
                           <a:solidFill>
                             <a:srgbClr val="333333"/>
                           </a:solidFill>
@@ -3962,7 +3909,7 @@
                         </a:defRPr>
                       </a:pPr>
                       <a:r>
-                        <a:t>416,161</a:t>
+                        <a:t>Medium</a:t>
                       </a:r>
                     </a:p>
                   </a:txBody>
@@ -3978,7 +3925,7 @@
                     <a:lstStyle/>
                     <a:p>
                       <a:pPr algn="ctr">
-                        <a:defRPr sz="1300">
+                        <a:defRPr sz="900">
                           <a:solidFill>
                             <a:srgbClr val="333333"/>
                           </a:solidFill>
@@ -3986,33 +3933,7 @@
                         </a:defRPr>
                       </a:pPr>
                       <a:r>
-                        <a:t>+6%</a:t>
-                      </a:r>
-                    </a:p>
-                  </a:txBody>
-                  <a:tcPr anchor="ctr">
-                    <a:solidFill>
-                      <a:srgbClr val="E5F6FD"/>
-                    </a:solidFill>
-                  </a:tcPr>
-                </a:tc>
-              </a:tr>
-              <a:tr h="386861">
-                <a:tc>
-                  <a:txBody>
-                    <a:bodyPr/>
-                    <a:lstStyle/>
-                    <a:p>
-                      <a:pPr algn="ctr">
-                        <a:defRPr sz="1300">
-                          <a:solidFill>
-                            <a:srgbClr val="333333"/>
-                          </a:solidFill>
-                          <a:latin typeface="Albert Sans"/>
-                        </a:defRPr>
-                      </a:pPr>
-                      <a:r>
-                        <a:t>Net income</a:t>
+                        <a:t>12–60 mo</a:t>
                       </a:r>
                     </a:p>
                   </a:txBody>
@@ -4028,7 +3949,7 @@
                     <a:lstStyle/>
                     <a:p>
                       <a:pPr algn="ctr">
-                        <a:defRPr sz="1300">
+                        <a:defRPr sz="900">
                           <a:solidFill>
                             <a:srgbClr val="333333"/>
                           </a:solidFill>
@@ -4036,105 +3957,7 @@
                         </a:defRPr>
                       </a:pPr>
                       <a:r>
-                        <a:t>112,010</a:t>
-                      </a:r>
-                    </a:p>
-                  </a:txBody>
-                  <a:tcPr anchor="ctr">
-                    <a:solidFill>
-                      <a:srgbClr val="E5F6FD"/>
-                    </a:solidFill>
-                  </a:tcPr>
-                </a:tc>
-                <a:tc>
-                  <a:txBody>
-                    <a:bodyPr/>
-                    <a:lstStyle/>
-                    <a:p>
-                      <a:pPr algn="ctr">
-                        <a:defRPr sz="1300">
-                          <a:solidFill>
-                            <a:srgbClr val="333333"/>
-                          </a:solidFill>
-                          <a:latin typeface="Albert Sans"/>
-                        </a:defRPr>
-                      </a:pPr>
-                      <a:r>
-                        <a:t>+19%</a:t>
-                      </a:r>
-                    </a:p>
-                  </a:txBody>
-                  <a:tcPr anchor="ctr">
-                    <a:solidFill>
-                      <a:srgbClr val="E5F6FD"/>
-                    </a:solidFill>
-                  </a:tcPr>
-                </a:tc>
-              </a:tr>
-              <a:tr h="386868">
-                <a:tc>
-                  <a:txBody>
-                    <a:bodyPr/>
-                    <a:lstStyle/>
-                    <a:p>
-                      <a:pPr algn="ctr">
-                        <a:defRPr sz="1300">
-                          <a:solidFill>
-                            <a:srgbClr val="333333"/>
-                          </a:solidFill>
-                          <a:latin typeface="Albert Sans"/>
-                        </a:defRPr>
-                      </a:pPr>
-                      <a:r>
-                        <a:t>Services net sales</a:t>
-                      </a:r>
-                    </a:p>
-                  </a:txBody>
-                  <a:tcPr anchor="ctr">
-                    <a:solidFill>
-                      <a:srgbClr val="E5F6FD"/>
-                    </a:solidFill>
-                  </a:tcPr>
-                </a:tc>
-                <a:tc>
-                  <a:txBody>
-                    <a:bodyPr/>
-                    <a:lstStyle/>
-                    <a:p>
-                      <a:pPr algn="ctr">
-                        <a:defRPr sz="1300">
-                          <a:solidFill>
-                            <a:srgbClr val="333333"/>
-                          </a:solidFill>
-                          <a:latin typeface="Albert Sans"/>
-                        </a:defRPr>
-                      </a:pPr>
-                      <a:r>
-                        <a:t>109,158</a:t>
-                      </a:r>
-                    </a:p>
-                  </a:txBody>
-                  <a:tcPr anchor="ctr">
-                    <a:solidFill>
-                      <a:srgbClr val="E5F6FD"/>
-                    </a:solidFill>
-                  </a:tcPr>
-                </a:tc>
-                <a:tc>
-                  <a:txBody>
-                    <a:bodyPr/>
-                    <a:lstStyle/>
-                    <a:p>
-                      <a:pPr algn="ctr">
-                        <a:defRPr sz="1300">
-                          <a:solidFill>
-                            <a:srgbClr val="333333"/>
-                          </a:solidFill>
-                          <a:latin typeface="Albert Sans"/>
-                        </a:defRPr>
-                      </a:pPr>
-                      <a:r>
-                        <a:t>+14%</a:t>
+                        <a:t>Renewals/deferred revenue; subscription growth; cloud gross margin</a:t>
                       </a:r>
                     </a:p>
                   </a:txBody>

</xml_diff>